<commit_message>
sd-02-006/007, README: no invented serverless read path, scale-out wording for McDonald's, API group complete
Co-Authored-By: Claude Opus 5.5 <noreply@anthropic.com>
Claude-Session: https://claude.ai/code/session_01McBLtMnJbTnB94NeVs8a2V
</commit_message>
<xml_diff>
--- a/system-design-101/vi/lessons/sd-02-006/slides/sd-02-006.pptx
+++ b/system-design-101/vi/lessons/sd-02-006/slides/sd-02-006.pptx
@@ -2477,7 +2477,7 @@
               <a:buNone/>
             </a:pPr>
             <a:r>
-              <a:rPr lang="en-US" sz="1800" b="1" spc="227" kern="0" dirty="0">
+              <a:rPr lang="en-US" sz="1800" b="1" spc="228" kern="0" dirty="0">
                 <a:solidFill>
                   <a:srgbClr val="9AA0B5"/>
                 </a:solidFill>
@@ -2485,10 +2485,10 @@
                 <a:ea typeface="Be Vietnam Pro" pitchFamily="34" charset="-122"/>
                 <a:cs typeface="Be Vietnam Pro" pitchFamily="34" charset="-120"/>
               </a:rPr>
-              <a:t>ĐỌC</a:t>
-            </a:r>
-            <a:r>
-              <a:rPr lang="en-US" sz="1800" b="1" spc="179" kern="0" dirty="0">
+              <a:t>CÓ</a:t>
+            </a:r>
+            <a:r>
+              <a:rPr lang="en-US" sz="1800" b="1" spc="225" kern="0" dirty="0">
                 <a:solidFill>
                   <a:srgbClr val="9AA0B5"/>
                 </a:solidFill>
@@ -2496,10 +2496,10 @@
                 <a:ea typeface="Be Vietnam Pro" pitchFamily="34" charset="-122"/>
                 <a:cs typeface="Be Vietnam Pro" pitchFamily="34" charset="-120"/>
               </a:rPr>
-              <a:t> VÀ</a:t>
-            </a:r>
-            <a:r>
-              <a:rPr lang="en-US" sz="1800" b="1" spc="222" kern="0" dirty="0">
+              <a:t> DÙNG,</a:t>
+            </a:r>
+            <a:r>
+              <a:rPr lang="en-US" sz="1800" b="1" spc="226" kern="0" dirty="0">
                 <a:solidFill>
                   <a:srgbClr val="9AA0B5"/>
                 </a:solidFill>
@@ -2507,10 +2507,10 @@
                 <a:ea typeface="Be Vietnam Pro" pitchFamily="34" charset="-122"/>
                 <a:cs typeface="Be Vietnam Pro" pitchFamily="34" charset="-120"/>
               </a:rPr>
-              <a:t> TRẢ</a:t>
-            </a:r>
-            <a:r>
-              <a:rPr lang="en-US" sz="1800" b="1" spc="228" kern="0" dirty="0">
+              <a:t> NGUỒN KHÔNG</a:t>
+            </a:r>
+            <a:r>
+              <a:rPr lang="en-US" sz="1800" b="1" spc="164" kern="0" dirty="0">
                 <a:solidFill>
                   <a:srgbClr val="9AA0B5"/>
                 </a:solidFill>
@@ -2518,18 +2518,7 @@
                 <a:ea typeface="Be Vietnam Pro" pitchFamily="34" charset="-122"/>
                 <a:cs typeface="Be Vietnam Pro" pitchFamily="34" charset="-120"/>
               </a:rPr>
-              <a:t> DỮ</a:t>
-            </a:r>
-            <a:r>
-              <a:rPr lang="en-US" sz="1800" b="1" spc="224" kern="0" dirty="0">
-                <a:solidFill>
-                  <a:srgbClr val="9AA0B5"/>
-                </a:solidFill>
-                <a:latin typeface="Be Vietnam Pro" pitchFamily="34" charset="0"/>
-                <a:ea typeface="Be Vietnam Pro" pitchFamily="34" charset="-122"/>
-                <a:cs typeface="Be Vietnam Pro" pitchFamily="34" charset="-120"/>
-              </a:rPr>
-              <a:t> LIỆU</a:t>
+              <a:t> TẢ</a:t>
             </a:r>
             <a:endParaRPr lang="en-US" sz="1800" dirty="0"/>
           </a:p>
@@ -4373,7 +4362,7 @@
               <a:buNone/>
             </a:pPr>
             <a:r>
-              <a:rPr lang="en-US" sz="2400" dirty="0" spc="4" kern="0">
+              <a:rPr lang="en-US" sz="2400" dirty="0" spc="0" kern="0">
                 <a:solidFill>
                   <a:srgbClr val="14161C"/>
                 </a:solidFill>
@@ -4381,7 +4370,18 @@
                 <a:ea typeface="Be Vietnam Pro" pitchFamily="34" charset="-122"/>
                 <a:cs typeface="Be Vietnam Pro" pitchFamily="34" charset="-120"/>
               </a:rPr>
-              <a:t>Hàm</a:t>
+              <a:t>Có</a:t>
+            </a:r>
+            <a:r>
+              <a:rPr lang="en-US" sz="2400" dirty="0" spc="3" kern="0">
+                <a:solidFill>
+                  <a:srgbClr val="14161C"/>
+                </a:solidFill>
+                <a:latin typeface="Be Vietnam Pro" pitchFamily="34" charset="0"/>
+                <a:ea typeface="Be Vietnam Pro" pitchFamily="34" charset="-122"/>
+                <a:cs typeface="Be Vietnam Pro" pitchFamily="34" charset="-120"/>
+              </a:rPr>
+              <a:t> dùng;</a:t>
             </a:r>
             <a:r>
               <a:rPr lang="en-US" sz="2400" dirty="0" spc="1" kern="0">
@@ -4392,10 +4392,10 @@
                 <a:ea typeface="Be Vietnam Pro" pitchFamily="34" charset="-122"/>
                 <a:cs typeface="Be Vietnam Pro" pitchFamily="34" charset="-120"/>
               </a:rPr>
-              <a:t> nhỏ</a:t>
-            </a:r>
-            <a:r>
-              <a:rPr lang="en-US" sz="2400" dirty="0" spc="-18" kern="0">
+              <a:t> nguồn không</a:t>
+            </a:r>
+            <a:r>
+              <a:rPr lang="en-US" sz="2400" dirty="0" spc="0" kern="0">
                 <a:solidFill>
                   <a:srgbClr val="14161C"/>
                 </a:solidFill>
@@ -4403,10 +4403,10 @@
                 <a:ea typeface="Be Vietnam Pro" pitchFamily="34" charset="-122"/>
                 <a:cs typeface="Be Vietnam Pro" pitchFamily="34" charset="-120"/>
               </a:rPr>
-              <a:t> trên</a:t>
-            </a:r>
-            <a:r>
-              <a:rPr lang="en-US" sz="2400" dirty="0" spc="2" kern="0">
+              <a:t> nói</a:t>
+            </a:r>
+            <a:r>
+              <a:rPr lang="en-US" sz="2400" dirty="0" spc="3" kern="0">
                 <a:solidFill>
                   <a:srgbClr val="14161C"/>
                 </a:solidFill>
@@ -4414,10 +4414,10 @@
                 <a:ea typeface="Be Vietnam Pro" pitchFamily="34" charset="-122"/>
                 <a:cs typeface="Be Vietnam Pro" pitchFamily="34" charset="-120"/>
               </a:rPr>
-              <a:t> hạ</a:t>
-            </a:r>
-            <a:r>
-              <a:rPr lang="en-US" sz="2400" dirty="0" spc="-7" kern="0">
+              <a:t> hàm làm</a:t>
+            </a:r>
+            <a:r>
+              <a:rPr lang="en-US" sz="2400" dirty="0" spc="1" kern="0">
                 <a:solidFill>
                   <a:srgbClr val="14161C"/>
                 </a:solidFill>
@@ -4425,84 +4425,7 @@
                 <a:ea typeface="Be Vietnam Pro" pitchFamily="34" charset="-122"/>
                 <a:cs typeface="Be Vietnam Pro" pitchFamily="34" charset="-120"/>
               </a:rPr>
-              <a:t> tầng</a:t>
-            </a:r>
-            <a:r>
-              <a:rPr lang="en-US" sz="2400" dirty="0" spc="2" kern="0">
-                <a:solidFill>
-                  <a:srgbClr val="14161C"/>
-                </a:solidFill>
-                <a:latin typeface="Be Vietnam Pro" pitchFamily="34" charset="0"/>
-                <a:ea typeface="Be Vietnam Pro" pitchFamily="34" charset="-122"/>
-                <a:cs typeface="Be Vietnam Pro" pitchFamily="34" charset="-120"/>
-              </a:rPr>
-              <a:t> nhà</a:t>
-            </a:r>
-            <a:r>
-              <a:rPr lang="en-US" sz="2400" dirty="0" spc="0" kern="0">
-                <a:solidFill>
-                  <a:srgbClr val="14161C"/>
-                </a:solidFill>
-                <a:latin typeface="Be Vietnam Pro" pitchFamily="34" charset="0"/>
-                <a:ea typeface="Be Vietnam Pro" pitchFamily="34" charset="-122"/>
-                <a:cs typeface="Be Vietnam Pro" pitchFamily="34" charset="-120"/>
-              </a:rPr>
-              <a:t> cung</a:t>
-            </a:r>
-            <a:r>
-              <a:rPr lang="en-US" sz="2400" dirty="0" spc="2" kern="0">
-                <a:solidFill>
-                  <a:srgbClr val="14161C"/>
-                </a:solidFill>
-                <a:latin typeface="Be Vietnam Pro" pitchFamily="34" charset="0"/>
-                <a:ea typeface="Be Vietnam Pro" pitchFamily="34" charset="-122"/>
-                <a:cs typeface="Be Vietnam Pro" pitchFamily="34" charset="-120"/>
-              </a:rPr>
-              <a:t> cấp,</a:t>
-            </a:r>
-            <a:r>
-              <a:rPr lang="en-US" sz="2400" dirty="0" spc="0" kern="0">
-                <a:solidFill>
-                  <a:srgbClr val="14161C"/>
-                </a:solidFill>
-                <a:latin typeface="Be Vietnam Pro" pitchFamily="34" charset="0"/>
-                <a:ea typeface="Be Vietnam Pro" pitchFamily="34" charset="-122"/>
-                <a:cs typeface="Be Vietnam Pro" pitchFamily="34" charset="-120"/>
-              </a:rPr>
-              <a:t> không</a:t>
-            </a:r>
-            <a:r>
-              <a:rPr lang="en-US" sz="2400" dirty="0" spc="4" kern="0">
-                <a:solidFill>
-                  <a:srgbClr val="14161C"/>
-                </a:solidFill>
-                <a:latin typeface="Be Vietnam Pro" pitchFamily="34" charset="0"/>
-                <a:ea typeface="Be Vietnam Pro" pitchFamily="34" charset="-122"/>
-                <a:cs typeface="Be Vietnam Pro" pitchFamily="34" charset="-120"/>
-              </a:rPr>
-              <a:t> tự</a:t>
-            </a:r>
-            <a:r>
-              <a:rPr lang="en-US" sz="2400" dirty="0" spc="1" kern="0">
-                <a:solidFill>
-                  <a:srgbClr val="14161C"/>
-                </a:solidFill>
-                <a:latin typeface="Be Vietnam Pro" pitchFamily="34" charset="0"/>
-                <a:ea typeface="Be Vietnam Pro" pitchFamily="34" charset="-122"/>
-                <a:cs typeface="Be Vietnam Pro" pitchFamily="34" charset="-120"/>
-              </a:rPr>
-              <a:t> quản</a:t>
-            </a:r>
-            <a:r>
-              <a:rPr lang="en-US" sz="2400" dirty="0" spc="-5" kern="0">
-                <a:solidFill>
-                  <a:srgbClr val="14161C"/>
-                </a:solidFill>
-                <a:latin typeface="Be Vietnam Pro" pitchFamily="34" charset="0"/>
-                <a:ea typeface="Be Vietnam Pro" pitchFamily="34" charset="-122"/>
-                <a:cs typeface="Be Vietnam Pro" pitchFamily="34" charset="-120"/>
-              </a:rPr>
-              <a:t> máy.</a:t>
+              <a:t> gì.</a:t>
             </a:r>
             <a:endParaRPr lang="en-US" sz="2400" dirty="0"/>
           </a:p>

</xml_diff>